<commit_message>
Logo: full mascot with its bags; a green leaf dots the i and falls into place
- The logo mark and app icons show the whole ResDish mascot: grocery bag, shoulder bag and feet.
- The dot of the i in "Dish" is a green leaf. In the website's SVG logos it drifts down, swaying, and settles on
  the i once when the logo appears (not for visitors who ask for less motion); PNGs for emails and PDFs show it
  in place.
- Videos re-recorded and the deck, proposal and checklist rebuilt with the new logo. Guide updated.

Co-Authored-By: Claude Opus 5.5 <noreply@anthropic.com>
Claude-Session: https://claude.ai/code/session_01TTXERQ5iqw3mLUpLGAhJam
</commit_message>
<xml_diff>
--- a/docs/business/ResDish-Restaurant-Sales-Pitch.pptx
+++ b/docs/business/ResDish-Restaurant-Sales-Pitch.pptx
@@ -116,36 +116,36 @@
   <p:extLst>
     <p:ext uri="{521415D9-36F7-43E2-AB2F-B90AF26B5E84}">
       <p14:sectionLst xmlns:p14="http://schemas.microsoft.com/office/powerpoint/2010/main">
-        <p14:section name="Opening" id="{e152fb30-b080-c762-a5c9-70dc93183d0a}">
+        <p14:section name="Opening" id="{f61494d8-63e2-b5f7-6410-022c3fc00a96}">
           <p14:sldIdLst>
             <p14:sldId id="256"/>
           </p14:sldIdLst>
         </p14:section>
-        <p14:section name="Why ResDish" id="{5aa87e4d-7286-0c21-3e70-2e013938a318}">
+        <p14:section name="Why ResDish" id="{8525e884-39f4-f595-965a-77a37855900a}">
           <p14:sldIdLst>
             <p14:sldId id="257"/>
             <p14:sldId id="258"/>
           </p14:sldIdLst>
         </p14:section>
-        <p14:section name="The product" id="{2decd14f-7656-6aca-d46b-3853975d60ea}">
+        <p14:section name="The product" id="{0f15b935-ea97-fdce-6d22-153dba07b437}">
           <p14:sldIdLst>
             <p14:sldId id="259"/>
             <p14:sldId id="260"/>
             <p14:sldId id="261"/>
           </p14:sldIdLst>
         </p14:section>
-        <p14:section name="Pricing" id="{9a0a6ceb-e2d6-54f9-4184-72286632d6bc}">
+        <p14:section name="Pricing" id="{65721fe8-fdfe-e37e-6137-061ff80b7bcd}">
           <p14:sldIdLst>
             <p14:sldId id="262"/>
             <p14:sldId id="263"/>
           </p14:sldIdLst>
         </p14:section>
-        <p14:section name="Trust" id="{4fdddcd0-8a1a-86cc-eb6c-9f452d7ff09f}">
+        <p14:section name="Trust" id="{5fccc868-1524-1445-eb8a-8cf5d74609c1}">
           <p14:sldIdLst>
             <p14:sldId id="264"/>
           </p14:sldIdLst>
         </p14:section>
-        <p14:section name="Next steps" id="{2fef5937-6c2e-8ea7-f0c9-96f5eec7638b}">
+        <p14:section name="Next steps" id="{49c251ac-1f08-3202-ac48-dae2c83c3072}">
           <p14:sldIdLst>
             <p14:sldId id="265"/>
           </p14:sldIdLst>

</xml_diff>

<commit_message>
New domain: www.resdish.com, support@resdish.com
Receipts, the sign-up email, default support and no-reply addresses, the settings example, the sales deck, the
partnership proposal and the go-live checklist use resdish.com instead of bite-wise.org. Guide updated.

Co-Authored-By: Claude Opus 5.5 <noreply@anthropic.com>
Claude-Session: https://claude.ai/code/session_01TTXERQ5iqw3mLUpLGAhJam
</commit_message>
<xml_diff>
--- a/docs/business/ResDish-Restaurant-Sales-Pitch.pptx
+++ b/docs/business/ResDish-Restaurant-Sales-Pitch.pptx
@@ -116,36 +116,36 @@
   <p:extLst>
     <p:ext uri="{521415D9-36F7-43E2-AB2F-B90AF26B5E84}">
       <p14:sectionLst xmlns:p14="http://schemas.microsoft.com/office/powerpoint/2010/main">
-        <p14:section name="Opening" id="{f61494d8-63e2-b5f7-6410-022c3fc00a96}">
+        <p14:section name="Opening" id="{deab2b8e-f152-cb3d-4e29-6f3ea4bc801a}">
           <p14:sldIdLst>
             <p14:sldId id="256"/>
           </p14:sldIdLst>
         </p14:section>
-        <p14:section name="Why ResDish" id="{8525e884-39f4-f595-965a-77a37855900a}">
+        <p14:section name="Why ResDish" id="{82c8ff37-c212-1904-1a8c-9beaf44f0fb3}">
           <p14:sldIdLst>
             <p14:sldId id="257"/>
             <p14:sldId id="258"/>
           </p14:sldIdLst>
         </p14:section>
-        <p14:section name="The product" id="{0f15b935-ea97-fdce-6d22-153dba07b437}">
+        <p14:section name="The product" id="{f2346c72-d999-1a13-54ee-509ea0aba328}">
           <p14:sldIdLst>
             <p14:sldId id="259"/>
             <p14:sldId id="260"/>
             <p14:sldId id="261"/>
           </p14:sldIdLst>
         </p14:section>
-        <p14:section name="Pricing" id="{65721fe8-fdfe-e37e-6137-061ff80b7bcd}">
+        <p14:section name="Pricing" id="{7c3bb0ad-23eb-3c0b-0650-c48a618274e4}">
           <p14:sldIdLst>
             <p14:sldId id="262"/>
             <p14:sldId id="263"/>
           </p14:sldIdLst>
         </p14:section>
-        <p14:section name="Trust" id="{5fccc868-1524-1445-eb8a-8cf5d74609c1}">
+        <p14:section name="Trust" id="{743d15a5-384f-7aeb-6291-ecce474efad5}">
           <p14:sldIdLst>
             <p14:sldId id="264"/>
           </p14:sldIdLst>
         </p14:section>
-        <p14:section name="Next steps" id="{49c251ac-1f08-3202-ac48-dae2c83c3072}">
+        <p14:section name="Next steps" id="{32f2060f-ba7a-797c-b07b-0465ecc896c9}">
           <p14:sldIdLst>
             <p14:sldId id="265"/>
           </p14:sldIdLst>
@@ -3212,7 +3212,7 @@
                   </a:extLst>
                 </a:hlinkClick>
               </a:rPr>
-              <a:t>www.bite-wise.org</a:t>
+              <a:t>www.resdish.com</a:t>
             </a:r>
             <a:endParaRPr lang="en-US" sz="1800" dirty="0"/>
           </a:p>
@@ -3233,7 +3233,7 @@
                   </a:extLst>
                 </a:hlinkClick>
               </a:rPr>
-              <a:t>support@bite-wise.org</a:t>
+              <a:t>support@resdish.com</a:t>
             </a:r>
             <a:endParaRPr lang="en-US" sz="1800" dirty="0"/>
           </a:p>

</xml_diff>